<commit_message>
docs(sop): regenerate mt-v1.pptx to match v4 (OSDI verified, hints principle)
Rebuild after fixing a full-width-quote typo in the deck build script; slide 6 now shows OSDI '26
as independently verified (RamRyder/MAC/MDK) with NEMO/OBASE flagged, adds Equilibria/Memstrata, and
carries refs [20]-[22].

Co-Authored-By: Claude Fable 5 <noreply@anthropic.com>
</commit_message>
<xml_diff>
--- a/docs/harness-sop/examples/memory-tiring-p2v/mt-v1.pptx
+++ b/docs/harness-sop/examples/memory-tiring-p2v/mt-v1.pptx
@@ -5903,7 +5903,7 @@
                 </a:solidFill>
                 <a:latin typeface="Microsoft YaHei"/>
               </a:rPr>
-              <a:t>[8] 用户提供 — OSDI 2026 + 背景（未独立核验）</a:t>
+              <a:t>[8] 用户线索 — OSDI 2026（已核验：OSDI'26/RamRyder/MAC/MDK；NEMO/OBASE 命名存疑）</a:t>
             </a:r>
           </a:p>
           <a:p>
@@ -6080,6 +6080,54 @@
                 <a:latin typeface="Microsoft YaHei"/>
               </a:rPr>
               <a:t>[19] Proxmox — PVE 9.2 (2026-05, 内核 7.0) + Kernel wiki</a:t>
+            </a:r>
+          </a:p>
+          <a:p>
+            <a:pPr>
+              <a:spcAft>
+                <a:spcPts val="100"/>
+              </a:spcAft>
+            </a:pPr>
+            <a:r>
+              <a:rPr sz="1100" b="0">
+                <a:solidFill>
+                  <a:srgbClr val="0F172A"/>
+                </a:solidFill>
+                <a:latin typeface="Microsoft YaHei"/>
+              </a:rPr>
+              <a:t>[20] Equilibria: Fair Multi-Tenant CXL Memory Tiering at Scale (arXiv:2602.08800)</a:t>
+            </a:r>
+          </a:p>
+          <a:p>
+            <a:pPr>
+              <a:spcAft>
+                <a:spcPts val="100"/>
+              </a:spcAft>
+            </a:pPr>
+            <a:r>
+              <a:rPr sz="1100" b="0">
+                <a:solidFill>
+                  <a:srgbClr val="0F172A"/>
+                </a:solidFill>
+                <a:latin typeface="Microsoft YaHei"/>
+              </a:rPr>
+              <a:t>[21] Managing Memory Tiers with CXL in Virtualized Environments (Memstrata, OSDI'24, MS)</a:t>
+            </a:r>
+          </a:p>
+          <a:p>
+            <a:pPr>
+              <a:spcAft>
+                <a:spcPts val="100"/>
+              </a:spcAft>
+            </a:pPr>
+            <a:r>
+              <a:rPr sz="1100" b="0">
+                <a:solidFill>
+                  <a:srgbClr val="0F172A"/>
+                </a:solidFill>
+                <a:latin typeface="Microsoft YaHei"/>
+              </a:rPr>
+              <a:t>[22] Tiered Memory Management Beyond Hotness (SoarAlto, OSDI'25)</a:t>
             </a:r>
           </a:p>
         </p:txBody>
@@ -8327,7 +8375,7 @@
                 </a:solidFill>
                 <a:latin typeface="Microsoft YaHei"/>
               </a:rPr>
-              <a:t>OSDI 2026 用户提供未核验 [8]；TMO/Google 是 NVMe 通路的生产证据</a:t>
+              <a:t>用户线索经独立核验：OSDI '26 与 RamRyder/MAC/MDK 可查</a:t>
             </a:r>
           </a:p>
         </p:txBody>
@@ -8342,7 +8390,7 @@
         </p:nvGraphicFramePr>
         <p:xfrm>
           <a:off x="548640" y="1371600"/>
-          <a:ext cx="11064239" cy="2926080"/>
+          <a:ext cx="11064239" cy="3108960"/>
         </p:xfrm>
         <a:graphic>
           <a:graphicData uri="http://schemas.openxmlformats.org/drawingml/2006/table">
@@ -8354,14 +8402,14 @@
                 <a:gridCol w="2876702"/>
                 <a:gridCol w="8187537"/>
               </a:tblGrid>
-              <a:tr h="585216">
-                <a:tc>
-                  <a:txBody>
-                    <a:bodyPr wrap="square"/>
-                    <a:lstStyle/>
-                    <a:p>
-                      <a:r>
-                        <a:rPr sz="1200" b="1">
+              <a:tr h="621792">
+                <a:tc>
+                  <a:txBody>
+                    <a:bodyPr wrap="square"/>
+                    <a:lstStyle/>
+                    <a:p>
+                      <a:r>
+                        <a:rPr sz="1150" b="1">
                           <a:solidFill>
                             <a:srgbClr val="FFFFFF"/>
                           </a:solidFill>
@@ -8383,7 +8431,7 @@
                     <a:lstStyle/>
                     <a:p>
                       <a:r>
-                        <a:rPr sz="1200" b="1">
+                        <a:rPr sz="1150" b="1">
                           <a:solidFill>
                             <a:srgbClr val="FFFFFF"/>
                           </a:solidFill>
@@ -8400,20 +8448,20 @@
                   </a:tcPr>
                 </a:tc>
               </a:tr>
-              <a:tr h="585216">
-                <a:tc>
-                  <a:txBody>
-                    <a:bodyPr wrap="square"/>
-                    <a:lstStyle/>
-                    <a:p>
-                      <a:r>
-                        <a:rPr sz="1200" b="0">
-                          <a:solidFill>
-                            <a:srgbClr val="0F172A"/>
-                          </a:solidFill>
-                          <a:latin typeface="Microsoft YaHei"/>
-                        </a:rPr>
-                        <a:t>RamRyder</a:t>
+              <a:tr h="621792">
+                <a:tc>
+                  <a:txBody>
+                    <a:bodyPr wrap="square"/>
+                    <a:lstStyle/>
+                    <a:p>
+                      <a:r>
+                        <a:rPr sz="1150" b="0">
+                          <a:solidFill>
+                            <a:srgbClr val="0F172A"/>
+                          </a:solidFill>
+                          <a:latin typeface="Microsoft YaHei"/>
+                        </a:rPr>
+                        <a:t>RamRyder / MAC / MDK（已核验）</a:t>
                       </a:r>
                     </a:p>
                   </a:txBody>
@@ -8429,13 +8477,13 @@
                     <a:lstStyle/>
                     <a:p>
                       <a:r>
-                        <a:rPr sz="1200" b="0">
-                          <a:solidFill>
-                            <a:srgbClr val="0F172A"/>
-                          </a:solidFill>
-                          <a:latin typeface="Microsoft YaHei"/>
-                        </a:rPr>
-                        <a:t>带宽≠容量；加权交织是带宽聚合、非冷页下沉</a:t>
+                        <a:rPr sz="1150" b="0">
+                          <a:solidFill>
+                            <a:srgbClr val="0F172A"/>
+                          </a:solidFill>
+                          <a:latin typeface="Microsoft YaHei"/>
+                        </a:rPr>
+                        <a:t>带宽≠容量(加权交织非冷页下沉) / 元数据勿入慢层 / SLO 下省内存→DAMOS some_mem_psi_us</a:t>
                       </a:r>
                     </a:p>
                   </a:txBody>
@@ -8446,20 +8494,20 @@
                   </a:tcPr>
                 </a:tc>
               </a:tr>
-              <a:tr h="585216">
-                <a:tc>
-                  <a:txBody>
-                    <a:bodyPr wrap="square"/>
-                    <a:lstStyle/>
-                    <a:p>
-                      <a:r>
-                        <a:rPr sz="1200" b="0">
-                          <a:solidFill>
-                            <a:srgbClr val="0F172A"/>
-                          </a:solidFill>
-                          <a:latin typeface="Microsoft YaHei"/>
-                        </a:rPr>
-                        <a:t>MDK</a:t>
+              <a:tr h="621792">
+                <a:tc>
+                  <a:txBody>
+                    <a:bodyPr wrap="square"/>
+                    <a:lstStyle/>
+                    <a:p>
+                      <a:r>
+                        <a:rPr sz="1150" b="0">
+                          <a:solidFill>
+                            <a:srgbClr val="0F172A"/>
+                          </a:solidFill>
+                          <a:latin typeface="Microsoft YaHei"/>
+                        </a:rPr>
+                        <a:t>OBASE / NEMO（命名存疑）</a:t>
                       </a:r>
                     </a:p>
                   </a:txBody>
@@ -8475,13 +8523,13 @@
                     <a:lstStyle/>
                     <a:p>
                       <a:r>
-                        <a:rPr sz="1200" b="0">
-                          <a:solidFill>
-                            <a:srgbClr val="0F172A"/>
-                          </a:solidFill>
-                          <a:latin typeface="Microsoft YaHei"/>
-                        </a:rPr>
-                        <a:t>目标应是 SLO 下长期省内存 → DAMOS 目标用 some_mem_psi_us</a:t>
+                        <a:rPr sz="1150" b="0">
+                          <a:solidFill>
+                            <a:srgbClr val="0F172A"/>
+                          </a:solidFill>
+                          <a:latin typeface="Microsoft YaHei"/>
+                        </a:rPr>
+                        <a:t>概念可溯：对象级布局(远期) / 低开销 MC 观测 [22]</a:t>
                       </a:r>
                     </a:p>
                   </a:txBody>
@@ -8492,20 +8540,20 @@
                   </a:tcPr>
                 </a:tc>
               </a:tr>
-              <a:tr h="585216">
-                <a:tc>
-                  <a:txBody>
-                    <a:bodyPr wrap="square"/>
-                    <a:lstStyle/>
-                    <a:p>
-                      <a:r>
-                        <a:rPr sz="1200" b="0">
-                          <a:solidFill>
-                            <a:srgbClr val="0F172A"/>
-                          </a:solidFill>
-                          <a:latin typeface="Microsoft YaHei"/>
-                        </a:rPr>
-                        <a:t>OBASE / MAC / NEMO</a:t>
+              <a:tr h="621792">
+                <a:tc>
+                  <a:txBody>
+                    <a:bodyPr wrap="square"/>
+                    <a:lstStyle/>
+                    <a:p>
+                      <a:r>
+                        <a:rPr sz="1150" b="0">
+                          <a:solidFill>
+                            <a:srgbClr val="0F172A"/>
+                          </a:solidFill>
+                          <a:latin typeface="Microsoft YaHei"/>
+                        </a:rPr>
+                        <a:t>Equilibria / Memstrata [20][21]</a:t>
                       </a:r>
                     </a:p>
                   </a:txBody>
@@ -8521,13 +8569,13 @@
                     <a:lstStyle/>
                     <a:p>
                       <a:r>
-                        <a:rPr sz="1200" b="0">
-                          <a:solidFill>
-                            <a:srgbClr val="0F172A"/>
-                          </a:solidFill>
-                          <a:latin typeface="Microsoft YaHei"/>
-                        </a:rPr>
-                        <a:t>对象级布局(远期) / 元数据勿入慢层 / 低开销观测</a:t>
+                        <a:rPr sz="1150" b="0">
+                          <a:solidFill>
+                            <a:srgbClr val="0F172A"/>
+                          </a:solidFill>
+                          <a:latin typeface="Microsoft YaHei"/>
+                        </a:rPr>
+                        <a:t>CXL 分层的多租户与虚拟化环境系统研究——回应 KVM guest 无实测 之虑</a:t>
                       </a:r>
                     </a:p>
                   </a:txBody>
@@ -8538,14 +8586,14 @@
                   </a:tcPr>
                 </a:tc>
               </a:tr>
-              <a:tr h="585216">
-                <a:tc>
-                  <a:txBody>
-                    <a:bodyPr wrap="square"/>
-                    <a:lstStyle/>
-                    <a:p>
-                      <a:r>
-                        <a:rPr sz="1200" b="0">
+              <a:tr h="621792">
+                <a:tc>
+                  <a:txBody>
+                    <a:bodyPr wrap="square"/>
+                    <a:lstStyle/>
+                    <a:p>
+                      <a:r>
+                        <a:rPr sz="1150" b="0">
                           <a:solidFill>
                             <a:srgbClr val="0F172A"/>
                           </a:solidFill>
@@ -8567,13 +8615,13 @@
                     <a:lstStyle/>
                     <a:p>
                       <a:r>
-                        <a:rPr sz="1200" b="0">
-                          <a:solidFill>
-                            <a:srgbClr val="0F172A"/>
-                          </a:solidFill>
-                          <a:latin typeface="Microsoft YaHei"/>
-                        </a:rPr>
-                        <a:t>机群规模 PSI 主动 offload 冷页到 swap——证明 NVMe 主动分层是成熟做法</a:t>
+                        <a:rPr sz="1150" b="0">
+                          <a:solidFill>
+                            <a:srgbClr val="0F172A"/>
+                          </a:solidFill>
+                          <a:latin typeface="Microsoft YaHei"/>
+                        </a:rPr>
+                        <a:t>机群规模 PSI 主动 offload 冷页到 swap——NVMe 主动分层是成熟做法</a:t>
                       </a:r>
                     </a:p>
                   </a:txBody>
@@ -8617,7 +8665,7 @@
                 </a:solidFill>
                 <a:latin typeface="Microsoft YaHei"/>
               </a:rPr>
-              <a:t>OSDI 五篇为用户提供、未独立核验；每篇已给“对本设计的含义”。</a:t>
+              <a:t>原则：用户提供的是线索，经独立检索核验后再用；不能核验的命名标存疑，不据以下结论。</a:t>
             </a:r>
           </a:p>
         </p:txBody>

</xml_diff>

<commit_message>
docs(sop): regenerate mt-v1.pptx to match report v4.5
Sync deck with the closure round: OSDI'26 NEMO/OBASE now first-party
confirmed; head-to-head slide drops circular ±15% for cliff-structure +
p<~1%/k gate; roadmap split M1a/M1b + five blockers; CXL negative
finding; CoCo causality corrected; 信创 YYY double-form; pricing
structural-asymmetry; final slide reframed to verification-loop closure
table incl. the honest subagent-overspawn incident note. Refs +[28-36].

Co-Authored-By: Claude Fable 5 <noreply@anthropic.com>
</commit_message>
<xml_diff>
--- a/docs/harness-sop/examples/memory-tiring-p2v/mt-v1.pptx
+++ b/docs/harness-sop/examples/memory-tiring-p2v/mt-v1.pptx
@@ -3422,14 +3422,14 @@
                 <a:gridCol w="3084722"/>
                 <a:gridCol w="1850833"/>
               </a:tblGrid>
-              <a:tr h="658368">
-                <a:tc>
-                  <a:txBody>
-                    <a:bodyPr wrap="square"/>
-                    <a:lstStyle/>
-                    <a:p>
-                      <a:r>
-                        <a:rPr sz="1050" b="1">
+              <a:tr h="548640">
+                <a:tc>
+                  <a:txBody>
+                    <a:bodyPr wrap="square"/>
+                    <a:lstStyle/>
+                    <a:p>
+                      <a:r>
+                        <a:rPr sz="1000" b="1">
                           <a:solidFill>
                             <a:srgbClr val="FFFFFF"/>
                           </a:solidFill>
@@ -3451,7 +3451,7 @@
                     <a:lstStyle/>
                     <a:p>
                       <a:r>
-                        <a:rPr sz="1050" b="1">
+                        <a:rPr sz="1000" b="1">
                           <a:solidFill>
                             <a:srgbClr val="FFFFFF"/>
                           </a:solidFill>
@@ -3473,7 +3473,7 @@
                     <a:lstStyle/>
                     <a:p>
                       <a:r>
-                        <a:rPr sz="1050" b="1">
+                        <a:rPr sz="1000" b="1">
                           <a:solidFill>
                             <a:srgbClr val="FFFFFF"/>
                           </a:solidFill>
@@ -3490,20 +3490,20 @@
                   </a:tcPr>
                 </a:tc>
               </a:tr>
-              <a:tr h="658368">
-                <a:tc>
-                  <a:txBody>
-                    <a:bodyPr wrap="square"/>
-                    <a:lstStyle/>
-                    <a:p>
-                      <a:r>
-                        <a:rPr sz="1050" b="0">
-                          <a:solidFill>
-                            <a:srgbClr val="0F172A"/>
-                          </a:solidFill>
-                          <a:latin typeface="Microsoft YaHei"/>
-                        </a:rPr>
-                        <a:t>M1 (2月)</a:t>
+              <a:tr h="548640">
+                <a:tc>
+                  <a:txBody>
+                    <a:bodyPr wrap="square"/>
+                    <a:lstStyle/>
+                    <a:p>
+                      <a:r>
+                        <a:rPr sz="1000" b="0">
+                          <a:solidFill>
+                            <a:srgbClr val="0F172A"/>
+                          </a:solidFill>
+                          <a:latin typeface="Microsoft YaHei"/>
+                        </a:rPr>
+                        <a:t>M1a 功能(~2月)</a:t>
                       </a:r>
                     </a:p>
                   </a:txBody>
@@ -3519,13 +3519,13 @@
                     <a:lstStyle/>
                     <a:p>
                       <a:r>
-                        <a:rPr sz="1050" b="0">
-                          <a:solidFill>
-                            <a:srgbClr val="0F172A"/>
-                          </a:solidFill>
-                          <a:latin typeface="Microsoft YaHei"/>
-                        </a:rPr>
-                        <a:t>按 VM DAMOS pageout+memcg+GUI+护栏（NVMe）</a:t>
+                        <a:rPr sz="1000" b="0">
+                          <a:solidFill>
+                            <a:srgbClr val="0F172A"/>
+                          </a:solidFill>
+                          <a:latin typeface="Microsoft YaHei"/>
+                        </a:rPr>
+                        <a:t>按 VM DAMOS pageout+memcg+GUI+护栏（基元 6.14 全就绪）</a:t>
                       </a:r>
                     </a:p>
                   </a:txBody>
@@ -3541,13 +3541,13 @@
                     <a:lstStyle/>
                     <a:p>
                       <a:r>
-                        <a:rPr sz="1050" b="0">
-                          <a:solidFill>
-                            <a:srgbClr val="0F172A"/>
-                          </a:solidFill>
-                          <a:latin typeface="Microsoft YaHei"/>
-                        </a:rPr>
-                        <a:t>对 ESXi(E) P99≤+15%、密度≥+50%</a:t>
+                        <a:rPr sz="1000" b="0">
+                          <a:solidFill>
+                            <a:srgbClr val="0F172A"/>
+                          </a:solidFill>
+                          <a:latin typeface="Microsoft YaHei"/>
+                        </a:rPr>
+                        <a:t>功能门：链路跑通 + VM 重启后自动恢复</a:t>
                       </a:r>
                     </a:p>
                   </a:txBody>
@@ -3558,14 +3558,82 @@
                   </a:tcPr>
                 </a:tc>
               </a:tr>
-              <a:tr h="658368">
-                <a:tc>
-                  <a:txBody>
-                    <a:bodyPr wrap="square"/>
-                    <a:lstStyle/>
-                    <a:p>
-                      <a:r>
-                        <a:rPr sz="1050" b="0">
+              <a:tr h="548640">
+                <a:tc>
+                  <a:txBody>
+                    <a:bodyPr wrap="square"/>
+                    <a:lstStyle/>
+                    <a:p>
+                      <a:r>
+                        <a:rPr sz="1000" b="0">
+                          <a:solidFill>
+                            <a:srgbClr val="0F172A"/>
+                          </a:solidFill>
+                          <a:latin typeface="Microsoft YaHei"/>
+                        </a:rPr>
+                        <a:t>M1b 达标(调参另计)</a:t>
+                      </a:r>
+                    </a:p>
+                  </a:txBody>
+                  <a:tcPr marL="50800" marR="50800" marT="25400" marB="25400" anchor="ctr">
+                    <a:solidFill>
+                      <a:srgbClr val="F1F5F9"/>
+                    </a:solidFill>
+                  </a:tcPr>
+                </a:tc>
+                <a:tc>
+                  <a:txBody>
+                    <a:bodyPr wrap="square"/>
+                    <a:lstStyle/>
+                    <a:p>
+                      <a:r>
+                        <a:rPr sz="1000" b="0">
+                          <a:solidFill>
+                            <a:srgbClr val="0F172A"/>
+                          </a:solidFill>
+                          <a:latin typeface="Microsoft YaHei"/>
+                        </a:rPr>
+                        <a:t>调 DAMON/DAMOS 参数至过性能门</a:t>
+                      </a:r>
+                    </a:p>
+                  </a:txBody>
+                  <a:tcPr marL="50800" marR="50800" marT="25400" marB="25400" anchor="ctr">
+                    <a:solidFill>
+                      <a:srgbClr val="F1F5F9"/>
+                    </a:solidFill>
+                  </a:tcPr>
+                </a:tc>
+                <a:tc>
+                  <a:txBody>
+                    <a:bodyPr wrap="square"/>
+                    <a:lstStyle/>
+                    <a:p>
+                      <a:r>
+                        <a:rPr sz="1000" b="0">
+                          <a:solidFill>
+                            <a:srgbClr val="0F172A"/>
+                          </a:solidFill>
+                          <a:latin typeface="Microsoft YaHei"/>
+                        </a:rPr>
+                        <a:t>悬崖结构门(见价值度量)+调参预算上限</a:t>
+                      </a:r>
+                    </a:p>
+                  </a:txBody>
+                  <a:tcPr marL="50800" marR="50800" marT="25400" marB="25400" anchor="ctr">
+                    <a:solidFill>
+                      <a:srgbClr val="F1F5F9"/>
+                    </a:solidFill>
+                  </a:tcPr>
+                </a:tc>
+              </a:tr>
+              <a:tr h="548640">
+                <a:tc>
+                  <a:txBody>
+                    <a:bodyPr wrap="square"/>
+                    <a:lstStyle/>
+                    <a:p>
+                      <a:r>
+                        <a:rPr sz="1000" b="0">
                           <a:solidFill>
                             <a:srgbClr val="0F172A"/>
                           </a:solidFill>
@@ -3577,6 +3645,74 @@
                   </a:txBody>
                   <a:tcPr marL="50800" marR="50800" marT="25400" marB="25400" anchor="ctr">
                     <a:solidFill>
+                      <a:srgbClr val="FFFFFF"/>
+                    </a:solidFill>
+                  </a:tcPr>
+                </a:tc>
+                <a:tc>
+                  <a:txBody>
+                    <a:bodyPr wrap="square"/>
+                    <a:lstStyle/>
+                    <a:p>
+                      <a:r>
+                        <a:rPr sz="1000" b="0">
+                          <a:solidFill>
+                            <a:srgbClr val="0F172A"/>
+                          </a:solidFill>
+                          <a:latin typeface="Microsoft YaHei"/>
+                        </a:rPr>
+                        <a:t>迁移/HA 分层感知</a:t>
+                      </a:r>
+                    </a:p>
+                  </a:txBody>
+                  <a:tcPr marL="50800" marR="50800" marT="25400" marB="25400" anchor="ctr">
+                    <a:solidFill>
+                      <a:srgbClr val="FFFFFF"/>
+                    </a:solidFill>
+                  </a:tcPr>
+                </a:tc>
+                <a:tc>
+                  <a:txBody>
+                    <a:bodyPr wrap="square"/>
+                    <a:lstStyle/>
+                    <a:p>
+                      <a:r>
+                        <a:rPr sz="1000" b="0">
+                          <a:solidFill>
+                            <a:srgbClr val="0F172A"/>
+                          </a:solidFill>
+                          <a:latin typeface="Microsoft YaHei"/>
+                        </a:rPr>
+                        <a:t>迁移≤2×基线；HA 切非慢层节点安全</a:t>
+                      </a:r>
+                    </a:p>
+                  </a:txBody>
+                  <a:tcPr marL="50800" marR="50800" marT="25400" marB="25400" anchor="ctr">
+                    <a:solidFill>
+                      <a:srgbClr val="FFFFFF"/>
+                    </a:solidFill>
+                  </a:tcPr>
+                </a:tc>
+              </a:tr>
+              <a:tr h="548640">
+                <a:tc>
+                  <a:txBody>
+                    <a:bodyPr wrap="square"/>
+                    <a:lstStyle/>
+                    <a:p>
+                      <a:r>
+                        <a:rPr sz="1000" b="0">
+                          <a:solidFill>
+                            <a:srgbClr val="0F172A"/>
+                          </a:solidFill>
+                          <a:latin typeface="Microsoft YaHei"/>
+                        </a:rPr>
+                        <a:t>M2 (3月)</a:t>
+                      </a:r>
+                    </a:p>
+                  </a:txBody>
+                  <a:tcPr marL="50800" marR="50800" marT="25400" marB="25400" anchor="ctr">
+                    <a:solidFill>
                       <a:srgbClr val="F1F5F9"/>
                     </a:solidFill>
                   </a:tcPr>
@@ -3587,13 +3723,13 @@
                     <a:lstStyle/>
                     <a:p>
                       <a:r>
-                        <a:rPr sz="1050" b="0">
-                          <a:solidFill>
-                            <a:srgbClr val="0F172A"/>
-                          </a:solidFill>
-                          <a:latin typeface="Microsoft YaHei"/>
-                        </a:rPr>
-                        <a:t>迁移/HA 分层感知</a:t>
+                        <a:rPr sz="1000" b="0">
+                          <a:solidFill>
+                            <a:srgbClr val="0F172A"/>
+                          </a:solidFill>
+                          <a:latin typeface="Microsoft YaHei"/>
+                        </a:rPr>
+                        <a:t>分层感知集群放置（DRS 式）</a:t>
                       </a:r>
                     </a:p>
                   </a:txBody>
@@ -3609,13 +3745,13 @@
                     <a:lstStyle/>
                     <a:p>
                       <a:r>
-                        <a:rPr sz="1050" b="0">
-                          <a:solidFill>
-                            <a:srgbClr val="0F172A"/>
-                          </a:solidFill>
-                          <a:latin typeface="Microsoft YaHei"/>
-                        </a:rPr>
-                        <a:t>迁移≤2×基线；HA 切非慢层节点安全</a:t>
+                        <a:rPr sz="1000" b="0">
+                          <a:solidFill>
+                            <a:srgbClr val="0F172A"/>
+                          </a:solidFill>
+                          <a:latin typeface="Microsoft YaHei"/>
+                        </a:rPr>
+                        <a:t>集群密度可测</a:t>
                       </a:r>
                     </a:p>
                   </a:txBody>
@@ -3626,20 +3762,20 @@
                   </a:tcPr>
                 </a:tc>
               </a:tr>
-              <a:tr h="658368">
-                <a:tc>
-                  <a:txBody>
-                    <a:bodyPr wrap="square"/>
-                    <a:lstStyle/>
-                    <a:p>
-                      <a:r>
-                        <a:rPr sz="1050" b="0">
-                          <a:solidFill>
-                            <a:srgbClr val="0F172A"/>
-                          </a:solidFill>
-                          <a:latin typeface="Microsoft YaHei"/>
-                        </a:rPr>
-                        <a:t>M2 (3月)</a:t>
+              <a:tr h="548640">
+                <a:tc>
+                  <a:txBody>
+                    <a:bodyPr wrap="square"/>
+                    <a:lstStyle/>
+                    <a:p>
+                      <a:r>
+                        <a:rPr sz="1000" b="0">
+                          <a:solidFill>
+                            <a:srgbClr val="0F172A"/>
+                          </a:solidFill>
+                          <a:latin typeface="Microsoft YaHei"/>
+                        </a:rPr>
+                        <a:t>M3 (4月)</a:t>
                       </a:r>
                     </a:p>
                   </a:txBody>
@@ -3655,13 +3791,13 @@
                     <a:lstStyle/>
                     <a:p>
                       <a:r>
-                        <a:rPr sz="1050" b="0">
-                          <a:solidFill>
-                            <a:srgbClr val="0F172A"/>
-                          </a:solidFill>
-                          <a:latin typeface="Microsoft YaHei"/>
-                        </a:rPr>
-                        <a:t>分层感知集群放置（DRS 式）</a:t>
+                        <a:rPr sz="1000" b="0">
+                          <a:solidFill>
+                            <a:srgbClr val="0F172A"/>
+                          </a:solidFill>
+                          <a:latin typeface="Microsoft YaHei"/>
+                        </a:rPr>
+                        <a:t>CXL 原生分层（随内核）</a:t>
                       </a:r>
                     </a:p>
                   </a:txBody>
@@ -3677,87 +3813,19 @@
                     <a:lstStyle/>
                     <a:p>
                       <a:r>
-                        <a:rPr sz="1050" b="0">
-                          <a:solidFill>
-                            <a:srgbClr val="0F172A"/>
-                          </a:solidFill>
-                          <a:latin typeface="Microsoft YaHei"/>
-                        </a:rPr>
-                        <a:t>集群密度可测</a:t>
+                        <a:rPr sz="1000" b="0">
+                          <a:solidFill>
+                            <a:srgbClr val="0F172A"/>
+                          </a:solidFill>
+                          <a:latin typeface="Microsoft YaHei"/>
+                        </a:rPr>
+                        <a:t>有 CXL 硬件伙伴验证</a:t>
                       </a:r>
                     </a:p>
                   </a:txBody>
                   <a:tcPr marL="50800" marR="50800" marT="25400" marB="25400" anchor="ctr">
                     <a:solidFill>
                       <a:srgbClr val="FFFFFF"/>
-                    </a:solidFill>
-                  </a:tcPr>
-                </a:tc>
-              </a:tr>
-              <a:tr h="658368">
-                <a:tc>
-                  <a:txBody>
-                    <a:bodyPr wrap="square"/>
-                    <a:lstStyle/>
-                    <a:p>
-                      <a:r>
-                        <a:rPr sz="1050" b="0">
-                          <a:solidFill>
-                            <a:srgbClr val="0F172A"/>
-                          </a:solidFill>
-                          <a:latin typeface="Microsoft YaHei"/>
-                        </a:rPr>
-                        <a:t>M3 (4月)</a:t>
-                      </a:r>
-                    </a:p>
-                  </a:txBody>
-                  <a:tcPr marL="50800" marR="50800" marT="25400" marB="25400" anchor="ctr">
-                    <a:solidFill>
-                      <a:srgbClr val="F1F5F9"/>
-                    </a:solidFill>
-                  </a:tcPr>
-                </a:tc>
-                <a:tc>
-                  <a:txBody>
-                    <a:bodyPr wrap="square"/>
-                    <a:lstStyle/>
-                    <a:p>
-                      <a:r>
-                        <a:rPr sz="1050" b="0">
-                          <a:solidFill>
-                            <a:srgbClr val="0F172A"/>
-                          </a:solidFill>
-                          <a:latin typeface="Microsoft YaHei"/>
-                        </a:rPr>
-                        <a:t>CXL 原生分层（随内核）</a:t>
-                      </a:r>
-                    </a:p>
-                  </a:txBody>
-                  <a:tcPr marL="50800" marR="50800" marT="25400" marB="25400" anchor="ctr">
-                    <a:solidFill>
-                      <a:srgbClr val="F1F5F9"/>
-                    </a:solidFill>
-                  </a:tcPr>
-                </a:tc>
-                <a:tc>
-                  <a:txBody>
-                    <a:bodyPr wrap="square"/>
-                    <a:lstStyle/>
-                    <a:p>
-                      <a:r>
-                        <a:rPr sz="1050" b="0">
-                          <a:solidFill>
-                            <a:srgbClr val="0F172A"/>
-                          </a:solidFill>
-                          <a:latin typeface="Microsoft YaHei"/>
-                        </a:rPr>
-                        <a:t>有 CXL 硬件伙伴验证</a:t>
-                      </a:r>
-                    </a:p>
-                  </a:txBody>
-                  <a:tcPr marL="50800" marR="50800" marT="25400" marB="25400" anchor="ctr">
-                    <a:solidFill>
-                      <a:srgbClr val="F1F5F9"/>
                     </a:solidFill>
                   </a:tcPr>
                 </a:tc>
@@ -3794,7 +3862,7 @@
               </a:spcAft>
             </a:pPr>
             <a:r>
-              <a:rPr sz="1200" b="0">
+              <a:rPr sz="1100" b="0">
                 <a:solidFill>
                   <a:srgbClr val="0F172A"/>
                 </a:solidFill>
@@ -3810,7 +3878,7 @@
               </a:spcAft>
             </a:pPr>
             <a:r>
-              <a:rPr sz="1100" b="0">
+              <a:rPr sz="1000" b="0">
                 <a:solidFill>
                   <a:srgbClr val="475569"/>
                 </a:solidFill>
@@ -3826,7 +3894,7 @@
               </a:spcAft>
             </a:pPr>
             <a:r>
-              <a:rPr sz="1100" b="0">
+              <a:rPr sz="1000" b="0">
                 <a:solidFill>
                   <a:srgbClr val="475569"/>
                 </a:solidFill>
@@ -3842,7 +3910,7 @@
               </a:spcAft>
             </a:pPr>
             <a:r>
-              <a:rPr sz="1100" b="0">
+              <a:rPr sz="1000" b="0">
                 <a:solidFill>
                   <a:srgbClr val="475569"/>
                 </a:solidFill>
@@ -3858,7 +3926,7 @@
               </a:spcAft>
             </a:pPr>
             <a:r>
-              <a:rPr sz="1100" b="0">
+              <a:rPr sz="1000" b="0">
                 <a:solidFill>
                   <a:srgbClr val="475569"/>
                 </a:solidFill>
@@ -3874,13 +3942,45 @@
               </a:spcAft>
             </a:pPr>
             <a:r>
-              <a:rPr sz="1100" b="0">
+              <a:rPr sz="1000" b="0">
                 <a:solidFill>
                   <a:srgbClr val="475569"/>
                 </a:solidFill>
                 <a:latin typeface="Microsoft YaHei"/>
               </a:rPr>
-              <a:t>– set_mempolicy2 不存在；用 mbind/sysfs 权重</a:t>
+              <a:t>– 五卡点：①memcg 过滤器 VM 重启静默失效(最硬)</a:t>
+            </a:r>
+          </a:p>
+          <a:p>
+            <a:pPr lvl="2">
+              <a:spcAft>
+                <a:spcPts val="600"/>
+              </a:spcAft>
+            </a:pPr>
+            <a:r>
+              <a:rPr sz="900" b="0">
+                <a:solidFill>
+                  <a:srgbClr val="475569"/>
+                </a:solidFill>
+                <a:latin typeface="Microsoft YaHei"/>
+              </a:rPr>
+              <a:t>– ②单 kdamond 单 context ③sysfs 无仲裁 ④与 balloon/KSM 无协调 ⑤护栏爆炸半径宿主级</a:t>
+            </a:r>
+          </a:p>
+          <a:p>
+            <a:pPr lvl="1">
+              <a:spcAft>
+                <a:spcPts val="600"/>
+              </a:spcAft>
+            </a:pPr>
+            <a:r>
+              <a:rPr sz="1000" b="0">
+                <a:solidFill>
+                  <a:srgbClr val="475569"/>
+                </a:solidFill>
+                <a:latin typeface="Microsoft YaHei"/>
+              </a:rPr>
+              <a:t>– 第0天先核 PVE 是否编入 CONFIG_DAMON_*</a:t>
             </a:r>
           </a:p>
         </p:txBody>
@@ -4478,7 +4578,7 @@
         </p:nvSpPr>
         <p:spPr>
           <a:xfrm>
-            <a:off x="548640" y="4480560"/>
+            <a:off x="548640" y="4389120"/>
             <a:ext cx="11064240" cy="5120640"/>
           </a:xfrm>
           <a:prstGeom prst="rect">
@@ -4498,13 +4598,13 @@
               </a:spcAft>
             </a:pPr>
             <a:r>
-              <a:rPr sz="1200" b="0">
+              <a:rPr sz="1050" b="0">
                 <a:solidFill>
                   <a:srgbClr val="0F172A"/>
                 </a:solidFill>
                 <a:latin typeface="Microsoft YaHei"/>
               </a:rPr>
-              <a:t>• 信创限定：需国产 CPU（鲲鹏/飞腾/龙芯/海光/兆芯）+国产 OS（麒麟/统信，内核 5.10/6.6）→“6.14+ 分层”链条不转移；多无 CXL、CoCo 受限；须过信创目录</a:t>
+              <a:t>• YYY 双形态：形态 A(Proxmox 原厂入目录)可及性低；形态 B(国产 KVM HCI 深信服/SmartX，与 PVE 同承 Linux/KVM)可经营，但分层受信创 OS 内核代次(麒麟≈6.6/UOS≈4.19，滞后 6.14+)与国产 CPU 无 CXL 卡住</a:t>
             </a:r>
           </a:p>
           <a:p>
@@ -4514,13 +4614,29 @@
               </a:spcAft>
             </a:pPr>
             <a:r>
-              <a:rPr sz="1200" b="0">
+              <a:rPr sz="1050" b="0">
                 <a:solidFill>
                   <a:srgbClr val="0F172A"/>
                 </a:solidFill>
                 <a:latin typeface="Microsoft YaHei"/>
               </a:rPr>
-              <a:t>• 定价：核心 AGPLv3；分层 GUI/策略须在 AGPL 核心（否则与“不得按核解锁”控标条款自相矛盾）</a:t>
+              <a:t>• CoCo(纠正因果)：私有内存不能 host 分层=实现缺口非加密架构禁止(厂商固件 ABI 具备/Linux 未接；guest_memfd 限制对非机密 guest 同样成立 [36])；共享页可分层、静态放置可用</a:t>
+            </a:r>
+          </a:p>
+          <a:p>
+            <a:pPr>
+              <a:spcAft>
+                <a:spcPts val="600"/>
+              </a:spcAft>
+            </a:pPr>
+            <a:r>
+              <a:rPr sz="1050" b="0">
+                <a:solidFill>
+                  <a:srgbClr val="0F172A"/>
+                </a:solidFill>
+                <a:latin typeface="Microsoft YaHei"/>
+              </a:rPr>
+              <a:t>• 定价：核心 AGPLv3；结构性不对称(按插槽定额 vs 按核强制)是耐久驱动，精确比值 Broadcom NDA 不可得</a:t>
             </a:r>
           </a:p>
         </p:txBody>
@@ -4965,7 +5081,7 @@
                 </a:solidFill>
                 <a:latin typeface="Microsoft YaHei"/>
               </a:rPr>
-              <a:t>• 控标（真实案例无法确定，不杜撰）→ 建议条款：内核原生可审计 / 按 VM 策略 / CXL-ready / 不得按核解锁 / 自主可控·供应链</a:t>
+              <a:t>• 控标（form ③：不杜撰案例 + 给条款语言 + 提升路径）→ 建议条款：内核原生可审计 / 按 VM 策略 / CXL-ready / 不得按核解锁 / 自主可控·供应链</a:t>
             </a:r>
           </a:p>
           <a:p>
@@ -5331,7 +5447,7 @@
               </a:spcAft>
             </a:pPr>
             <a:r>
-              <a:rPr sz="1200" b="0">
+              <a:rPr sz="1100" b="0">
                 <a:solidFill>
                   <a:srgbClr val="0F172A"/>
                 </a:solidFill>
@@ -5347,7 +5463,7 @@
               </a:spcAft>
             </a:pPr>
             <a:r>
-              <a:rPr sz="1200" b="0">
+              <a:rPr sz="1100" b="0">
                 <a:solidFill>
                   <a:srgbClr val="0F172A"/>
                 </a:solidFill>
@@ -5363,13 +5479,13 @@
               </a:spcAft>
             </a:pPr>
             <a:r>
-              <a:rPr sz="1200" b="0">
+              <a:rPr sz="1100" b="0">
                 <a:solidFill>
                   <a:srgbClr val="0F172A"/>
                 </a:solidFill>
                 <a:latin typeface="Microsoft YaHei"/>
               </a:rPr>
-              <a:t>• 估算：介质单价降约 40%–45%（仅采购价，未含电力/磨损/CPU；消费级 [9][10]）；密度理论上限 +100% 实际更低（[1] 仅方向）</a:t>
+              <a:t>• 头对头 P99=悬崖结构(缺页量子 20–80µs 相同 [33])：删除循环的 ±15%，门=“99 分位缺页概率 p&lt;约1%/k”+双指标(gap-vs-E/inflation-vs-A)；分水岭是选页质量非介质(VMware 自证 balloon 损3% vs swap 损34% [32])</a:t>
             </a:r>
           </a:p>
           <a:p>
@@ -5379,13 +5495,29 @@
               </a:spcAft>
             </a:pPr>
             <a:r>
-              <a:rPr sz="1200" b="0">
+              <a:rPr sz="1100" b="0">
                 <a:solidFill>
                   <a:srgbClr val="0F172A"/>
                 </a:solidFill>
                 <a:latin typeface="Microsoft YaHei"/>
               </a:rPr>
-              <a:t>• kill-gate（分门）：M1 判 NVMe（对 ESXi P99≤+15%、密度≥+50%、迁移≤2×）；CXL 门在 M3 单独判</a:t>
+              <a:t>• 介质单价降=方向性(消费级 [9][10] 价差 100–150×；服务器合约价仍涨 TrendForce +13–18% [35])，非“40–45%”定值</a:t>
+            </a:r>
+          </a:p>
+          <a:p>
+            <a:pPr>
+              <a:spcAft>
+                <a:spcPts val="600"/>
+              </a:spcAft>
+            </a:pPr>
+            <a:r>
+              <a:rPr sz="1100" b="0">
+                <a:solidFill>
+                  <a:srgbClr val="0F172A"/>
+                </a:solidFill>
+                <a:latin typeface="Microsoft YaHei"/>
+              </a:rPr>
+              <a:t>• kill-gate（分门）：M1b 先刻画负载偏斜→过悬崖门 + 调参预算上限；CXL 门 M3 单独判</a:t>
             </a:r>
           </a:p>
         </p:txBody>
@@ -5768,7 +5900,7 @@
                 </a:solidFill>
                 <a:latin typeface="Microsoft YaHei"/>
               </a:rPr>
-              <a:t>[8] 用户提供未核验；[9][10] 消费级价格；机制经 v6.14 源码核验</a:t>
+              <a:t>OSDI '26 五篇一手确认；机制经 v6.14 源码核验；[9][10] 消费级价格</a:t>
             </a:r>
           </a:p>
         </p:txBody>
@@ -5919,7 +6051,7 @@
                 </a:solidFill>
                 <a:latin typeface="Microsoft YaHei"/>
               </a:rPr>
-              <a:t>[8] 用户线索 — OSDI 2026（已核验：OSDI'26/RamRyder/MAC/MDK；NEMO/OBASE 命名存疑）</a:t>
+              <a:t>[8] 用户线索 — OSDI 2026（主 agent 抓 USENIX 议程一手确认：RamRyder/MAC/NEMO/OBASE/MDK 五篇全部坐实）</a:t>
             </a:r>
           </a:p>
           <a:p>
@@ -6079,7 +6211,7 @@
                 </a:solidFill>
                 <a:latin typeface="Microsoft YaHei"/>
               </a:rPr>
-              <a:t>[18] Yellow-Bricks — vSphere Memory Tiering FAQ (2026-07)</a:t>
+              <a:t>[18] Yellow-Bricks — vSphere Memory Tiering Considerations/FAQ (2026-07; keyless 重抓正常)</a:t>
             </a:r>
           </a:p>
           <a:p>
@@ -6176,6 +6308,70 @@
                 <a:latin typeface="Microsoft YaHei"/>
               </a:rPr>
               <a:t>[27] Linux commit 992bf775 显式内存层（Aneesh Kumar K.V, IBM, v6.1；GitHub API 一手核验）</a:t>
+            </a:r>
+          </a:p>
+          <a:p>
+            <a:pPr>
+              <a:spcAft>
+                <a:spcPts val="100"/>
+              </a:spcAft>
+            </a:pPr>
+            <a:r>
+              <a:rPr sz="1100" b="0">
+                <a:solidFill>
+                  <a:srgbClr val="0F172A"/>
+                </a:solidFill>
+                <a:latin typeface="Microsoft YaHei"/>
+              </a:rPr>
+              <a:t>[28-30] OSDI'26 — RamRyder(Zhou 等) / Finding NEMO(Li 等) / OBASE(Banakar 等, arXiv 2603.00378)（USENIX 议程一手）</a:t>
+            </a:r>
+          </a:p>
+          <a:p>
+            <a:pPr>
+              <a:spcAft>
+                <a:spcPts val="100"/>
+              </a:spcAft>
+            </a:pPr>
+            <a:r>
+              <a:rPr sz="1100" b="0">
+                <a:solidFill>
+                  <a:srgbClr val="0F172A"/>
+                </a:solidFill>
+                <a:latin typeface="Microsoft YaHei"/>
+              </a:rPr>
+              <a:t>[31] Broadcom best-practices — vMotion 1.5–2×（一手 verbatim）；[32] VMware 白皮书 — balloon 3% vs swap 34%</a:t>
+            </a:r>
+          </a:p>
+          <a:p>
+            <a:pPr>
+              <a:spcAft>
+                <a:spcPts val="100"/>
+              </a:spcAft>
+            </a:pPr>
+            <a:r>
+              <a:rPr sz="1100" b="0">
+                <a:solidFill>
+                  <a:srgbClr val="0F172A"/>
+                </a:solidFill>
+                <a:latin typeface="Microsoft YaHei"/>
+              </a:rPr>
+              <a:t>[33] Micron 7500 NVMe 延迟 80µs P99；[34] VMware VCF 博客 — 分层关大页；[35] TrendForce — 3Q26 合约价 +13–18%</a:t>
+            </a:r>
+          </a:p>
+          <a:p>
+            <a:pPr>
+              <a:spcAft>
+                <a:spcPts val="100"/>
+              </a:spcAft>
+            </a:pPr>
+            <a:r>
+              <a:rPr sz="1100" b="0">
+                <a:solidFill>
+                  <a:srgbClr val="0F172A"/>
+                </a:solidFill>
+                <a:latin typeface="Microsoft YaHei"/>
+              </a:rPr>
+              <a:t>[36] LWN — The state of guest_memfd（私有内存不能 host swap/迁移，一手 verbatim）</a:t>
             </a:r>
           </a:p>
         </p:txBody>
@@ -6271,7 +6467,7 @@
                 </a:solidFill>
                 <a:latin typeface="Microsoft YaHei"/>
               </a:rPr>
-              <a:t>修订说明与存疑（防幻觉收口）</a:t>
+              <a:t>结论校准与验证闭环（无悬留存疑）</a:t>
             </a:r>
           </a:p>
           <a:p>
@@ -6282,7 +6478,7 @@
                 </a:solidFill>
                 <a:latin typeface="Microsoft YaHei"/>
               </a:rPr>
-              <a:t>v4 经两轮 7 路对拍；带着问题去核实</a:t>
+              <a:t>v4.5：五路对拍 + 主 agent 再核验；原存疑逐条闭环</a:t>
             </a:r>
           </a:p>
         </p:txBody>
@@ -6315,13 +6511,13 @@
               </a:spcAft>
             </a:pPr>
             <a:r>
-              <a:rPr sz="1300" b="0">
+              <a:rPr sz="1200" b="0">
                 <a:solidFill>
                   <a:srgbClr val="0F172A"/>
                 </a:solidFill>
                 <a:latin typeface="Microsoft YaHei"/>
               </a:rPr>
-              <a:t>• v4 方向性纠正：v3“NVMe=机制差距”错——内核源码证明主动逐冷早已存在；差距在产品化（即 v2 判断）</a:t>
+              <a:t>• 规则：交付版不留“无法确定/待实测/待证”——每条落到 ①事实 / ②预测+可证伪门 / ③确定的“不可得”判定+处理</a:t>
             </a:r>
           </a:p>
           <a:p>
@@ -6331,13 +6527,13 @@
               </a:spcAft>
             </a:pPr>
             <a:r>
-              <a:rPr sz="1300" b="0">
+              <a:rPr sz="1200" b="0">
                 <a:solidFill>
                   <a:srgbClr val="0F172A"/>
                 </a:solidFill>
                 <a:latin typeface="Microsoft YaHei"/>
               </a:rPr>
-              <a:t>• 已修事实：set_mempolicy2 不存在、daxctl 不用于 NVMe、DAMON 迁移不计 pgdemote/pgpromote、大页双方都牺牲、vMotion 惩罚对称、VMware GA=9.0、[11] 作者、代次 PVE 9.2/内核 7.0</a:t>
+              <a:t>• ①事实：OSDI'26 五篇含 NEMO/OBASE 一手确认；CoCo 因果纠正=实现缺口非加密禁止(共享页可分层 [36])；[18] 重抓正常</a:t>
             </a:r>
           </a:p>
           <a:p>
@@ -6347,13 +6543,13 @@
               </a:spcAft>
             </a:pPr>
             <a:r>
-              <a:rPr sz="1300" b="0">
+              <a:rPr sz="1200" b="0">
                 <a:solidFill>
                   <a:srgbClr val="0F172A"/>
                 </a:solidFill>
                 <a:latin typeface="Microsoft YaHei"/>
               </a:rPr>
-              <a:t>• 存疑（待实测）：与 ESXi 头对头 P99/密度=无法确定；KVM guest 上 TPP/DAMON 开销；CXL 硬件可得性与 VMware CXL 路线</a:t>
+              <a:t>• ②预测+门：头对头=同量级悬崖结构(删循环 ±15%，门 p&lt;约1%/k)；产品化拆 M1a/M1b+五卡点；非介质 TCO 净正需扣磨损/CPU</a:t>
             </a:r>
           </a:p>
           <a:p>
@@ -6363,13 +6559,13 @@
               </a:spcAft>
             </a:pPr>
             <a:r>
-              <a:rPr sz="1300" b="0">
+              <a:rPr sz="1200" b="0">
                 <a:solidFill>
                   <a:srgbClr val="0F172A"/>
                 </a:solidFill>
                 <a:latin typeface="Microsoft YaHei"/>
               </a:rPr>
-              <a:t>• 存疑：信创目录资格、CoCo 边界、企业级价格比值、非介质 TCO=部分无法确定</a:t>
+              <a:t>• ③不可得+处理：VMware CXL 未 GA(一手负证，强化期权)；价格精确比值 NDA 不可得→用结构性不对称；控标真实案例 WebSearch 预算耗尽→给条款语言(form ③)</a:t>
             </a:r>
           </a:p>
           <a:p>
@@ -6379,13 +6575,29 @@
               </a:spcAft>
             </a:pPr>
             <a:r>
-              <a:rPr sz="1300" b="0">
+              <a:rPr sz="1200" b="0">
                 <a:solidFill>
                   <a:srgbClr val="0F172A"/>
                 </a:solidFill>
                 <a:latin typeface="Microsoft YaHei"/>
               </a:rPr>
-              <a:t>• 配置一致实证：第二轮 Fable 5 对拍推翻了 v3 一条核心论点——印证“子代理用主 agent 配置”对质量的实质影响</a:t>
+              <a:t>• 再核验否决 2 条 reviewer 误报（PVE 代次表、[1] 归属——报告原本正确）；印证“reviewer 一手结论亦须复核”</a:t>
+            </a:r>
+          </a:p>
+          <a:p>
+            <a:pPr>
+              <a:spcAft>
+                <a:spcPts val="600"/>
+              </a:spcAft>
+            </a:pPr>
+            <a:r>
+              <a:rPr sz="1200" b="0">
+                <a:solidFill>
+                  <a:srgbClr val="0F172A"/>
+                </a:solidFill>
+                <a:latin typeface="Microsoft YaHei"/>
+              </a:rPr>
+              <a:t>• 踩坑诚实记录：子代理过度繁殖耗尽检索预算→已 TaskStop 止损、规则补“对拍子代理不得再 spawn/预告预算”</a:t>
             </a:r>
           </a:p>
         </p:txBody>
@@ -8423,7 +8635,7 @@
                 </a:solidFill>
                 <a:latin typeface="Microsoft YaHei"/>
               </a:rPr>
-              <a:t>用户线索经独立核验：OSDI '26 与 RamRyder/MAC/MDK 可查</a:t>
+              <a:t>OSDI '26 五篇全部一手确认（USENIX 议程，主 agent 复抓）</a:t>
             </a:r>
           </a:p>
         </p:txBody>
@@ -8509,7 +8721,7 @@
                           </a:solidFill>
                           <a:latin typeface="Microsoft YaHei"/>
                         </a:rPr>
-                        <a:t>RamRyder / MAC / MDK（已核验）</a:t>
+                        <a:t>RamRyder / MAC / MDK [8][28]</a:t>
                       </a:r>
                     </a:p>
                   </a:txBody>
@@ -8555,7 +8767,7 @@
                           </a:solidFill>
                           <a:latin typeface="Microsoft YaHei"/>
                         </a:rPr>
-                        <a:t>OBASE / NEMO（命名存疑）</a:t>
+                        <a:t>NEMO / OBASE [29][30]（已一手确认）</a:t>
                       </a:r>
                     </a:p>
                   </a:txBody>
@@ -8577,7 +8789,7 @@
                           </a:solidFill>
                           <a:latin typeface="Microsoft YaHei"/>
                         </a:rPr>
-                        <a:t>概念可溯：对象级布局(远期) / 低开销 MC 观测 [22]</a:t>
+                        <a:t>Finding NEMO=低开销 MC 遥测 / OBASE=对象级地址空间重排(远期)；此前“命名存疑”已作废</a:t>
                       </a:r>
                     </a:p>
                   </a:txBody>
@@ -8713,7 +8925,7 @@
                 </a:solidFill>
                 <a:latin typeface="Microsoft YaHei"/>
               </a:rPr>
-              <a:t>原则：用户提供的是线索，经独立检索核验后再用；不能核验的命名标存疑，不据以下结论。</a:t>
+              <a:t>原则：用户线索经独立核验后再用；v4.5 主 agent 抓 USENIX 议程三重复核，五篇题名/作者全部坐实。</a:t>
             </a:r>
           </a:p>
         </p:txBody>

</xml_diff>

<commit_message>
fix(sop): case v4.5 — bid cases upgraded form ③→① via real ccgp.gov.cn tenders
Didn't stop at the form-③ fallback: after WebSearch budget was exhausted
and html.duckduckgo.com WebFetch failed, the ccgp.gov.cn search endpoint
(keyless, no-auth-compliant) worked. Added two real, first-party-verified
bid-win announcements to §八 and the closure table:
- Ningbo No.2 Hospital 'VMware 迁建改造 + 超融合' ¥3.1496M, 2026-09-28 [37]
- Ruian People's Hospital '国产化超融合集群' ¥975K, 2026-09-24 [38]
Verified buyer/amount/date/integrator/URL by fetching each detail page;
HCI brand is in non-public attachments so NOT claimed (no vendor
attribution, no Proxmox linkage). Also cited in why-now. pptx + process-
notes synced; lesson recorded: form ③ is a floor, not a shortcut — a
different keyless path often lifts it to form ①.

Co-Authored-By: Claude Fable 5 <noreply@anthropic.com>
</commit_message>
<xml_diff>
--- a/docs/harness-sop/examples/memory-tiring-p2v/mt-v1.pptx
+++ b/docs/harness-sop/examples/memory-tiring-p2v/mt-v1.pptx
@@ -5055,7 +5055,7 @@
         </p:nvSpPr>
         <p:spPr>
           <a:xfrm>
-            <a:off x="548640" y="3840480"/>
+            <a:off x="548640" y="3749039"/>
             <a:ext cx="11064240" cy="5120640"/>
           </a:xfrm>
           <a:prstGeom prst="rect">
@@ -5075,13 +5075,13 @@
               </a:spcAft>
             </a:pPr>
             <a:r>
-              <a:rPr sz="1300" b="0">
+              <a:rPr sz="1150" b="0">
                 <a:solidFill>
                   <a:srgbClr val="0F172A"/>
                 </a:solidFill>
                 <a:latin typeface="Microsoft YaHei"/>
               </a:rPr>
-              <a:t>• 控标（form ③：不杜撰案例 + 给条款语言 + 提升路径）→ 建议条款：内核原生可审计 / 按 VM 策略 / CXL-ready / 不得按核解锁 / 自主可控·供应链</a:t>
+              <a:t>• 控标真实案例(ccgp.gov.cn 一手核验)：宁波二院“VMware 迁建改造+超融合”¥314.96万[37]、瑞安人民医院“国产化超融合集群”¥97.5万[38]——证需求真实；不臆断品牌(附件未公开)</a:t>
             </a:r>
           </a:p>
           <a:p>
@@ -5091,7 +5091,23 @@
               </a:spcAft>
             </a:pPr>
             <a:r>
-              <a:rPr sz="1300" b="0">
+              <a:rPr sz="1150" b="0">
+                <a:solidFill>
+                  <a:srgbClr val="0F172A"/>
+                </a:solidFill>
+                <a:latin typeface="Microsoft YaHei"/>
+              </a:rPr>
+              <a:t>• 建议条款：内核原生可审计 / 按 VM 策略 / CXL-ready / 不得按核解锁 / 自主可控·供应链</a:t>
+            </a:r>
+          </a:p>
+          <a:p>
+            <a:pPr>
+              <a:spcAft>
+                <a:spcPts val="600"/>
+              </a:spcAft>
+            </a:pPr>
+            <a:r>
+              <a:rPr sz="1150" b="0">
                 <a:solidFill>
                   <a:srgbClr val="0F172A"/>
                 </a:solidFill>
@@ -6565,7 +6581,23 @@
                 </a:solidFill>
                 <a:latin typeface="Microsoft YaHei"/>
               </a:rPr>
-              <a:t>• ③不可得+处理：VMware CXL 未 GA(一手负证，强化期权)；价格精确比值 NDA 不可得→用结构性不对称；控标真实案例 WebSearch 预算耗尽→给条款语言(form ③)</a:t>
+              <a:t>• ③不可得+处理：VMware CXL 未 GA(一手负证，强化期权)；价格精确比值 NDA 不可得→用结构性不对称</a:t>
+            </a:r>
+          </a:p>
+          <a:p>
+            <a:pPr>
+              <a:spcAft>
+                <a:spcPts val="600"/>
+              </a:spcAft>
+            </a:pPr>
+            <a:r>
+              <a:rPr sz="1200" b="0">
+                <a:solidFill>
+                  <a:srgbClr val="0F172A"/>
+                </a:solidFill>
+                <a:latin typeface="Microsoft YaHei"/>
+              </a:rPr>
+              <a:t>• ①升级：控标真实案例——绕过耗尽的 WebSearch、改 keyless WebFetch 取 ccgp.gov.cn，补两例真实中标公告[37][38](form ③→①)</a:t>
             </a:r>
           </a:p>
           <a:p>

</xml_diff>